<commit_message>
NEA COmpleted till session 4
</commit_message>
<xml_diff>
--- a/NEA/Recorded Lectures/1426769_81212_rl2.4.3.pptx
+++ b/NEA/Recorded Lectures/1426769_81212_rl2.4.3.pptx
@@ -5,21 +5,20 @@
     <p:sldMasterId id="2147483668" r:id="rId1"/>
   </p:sldMasterIdLst>
   <p:notesMasterIdLst>
-    <p:notesMasterId r:id="rId11"/>
+    <p:notesMasterId r:id="rId10"/>
   </p:notesMasterIdLst>
   <p:handoutMasterIdLst>
-    <p:handoutMasterId r:id="rId12"/>
+    <p:handoutMasterId r:id="rId11"/>
   </p:handoutMasterIdLst>
   <p:sldIdLst>
-    <p:sldId id="256" r:id="rId2"/>
-    <p:sldId id="283" r:id="rId3"/>
-    <p:sldId id="292" r:id="rId4"/>
-    <p:sldId id="299" r:id="rId5"/>
-    <p:sldId id="300" r:id="rId6"/>
-    <p:sldId id="301" r:id="rId7"/>
-    <p:sldId id="296" r:id="rId8"/>
-    <p:sldId id="297" r:id="rId9"/>
-    <p:sldId id="302" r:id="rId10"/>
+    <p:sldId id="283" r:id="rId2"/>
+    <p:sldId id="292" r:id="rId3"/>
+    <p:sldId id="299" r:id="rId4"/>
+    <p:sldId id="300" r:id="rId5"/>
+    <p:sldId id="301" r:id="rId6"/>
+    <p:sldId id="296" r:id="rId7"/>
+    <p:sldId id="297" r:id="rId8"/>
+    <p:sldId id="302" r:id="rId9"/>
   </p:sldIdLst>
   <p:sldSz cx="9144000" cy="6858000" type="screen4x3"/>
   <p:notesSz cx="6805613" cy="9944100"/>
@@ -236,10 +235,6 @@
 </p:presentation>
 </file>
 
-<file path=ppt/revisionInfo.xml><?xml version="1.0" encoding="utf-8"?>
-<p1510:revInfo xmlns:a="http://schemas.openxmlformats.org/drawingml/2006/main" xmlns:r="http://schemas.openxmlformats.org/officeDocument/2006/relationships" xmlns:p1510="http://schemas.microsoft.com/office/powerpoint/2015/10/main"/>
-</file>
-
 <file path=ppt/handoutMasters/handoutMaster1.xml><?xml version="1.0" encoding="utf-8"?>
 <p:handoutMaster xmlns:a="http://schemas.openxmlformats.org/drawingml/2006/main" xmlns:r="http://schemas.openxmlformats.org/officeDocument/2006/relationships" xmlns:p="http://schemas.openxmlformats.org/presentationml/2006/main">
   <p:cSld>
@@ -322,7 +317,7 @@
           <a:p>
             <a:fld id="{73BE9B4E-3786-43E4-ADC0-DE2945E09898}" type="datetimeFigureOut">
               <a:rPr lang="en-IN" smtClean="0"/>
-              <a:t>05-09-2017</a:t>
+              <a:t>17-04-2025</a:t>
             </a:fld>
             <a:endParaRPr lang="en-IN"/>
           </a:p>
@@ -983,851 +978,7 @@
 </p:notesMaster>
 </file>
 
-<file path=ppt/notesSlides/notesSlide1.xml><?xml version="1.0" encoding="utf-8"?>
-<p:notes xmlns:a="http://schemas.openxmlformats.org/drawingml/2006/main" xmlns:r="http://schemas.openxmlformats.org/officeDocument/2006/relationships" xmlns:p="http://schemas.openxmlformats.org/presentationml/2006/main" showMasterSp="0" showMasterPhAnim="0">
-  <p:cSld>
-    <p:spTree>
-      <p:nvGrpSpPr>
-        <p:cNvPr id="1" name="Shape 239"/>
-        <p:cNvGrpSpPr/>
-        <p:nvPr/>
-      </p:nvGrpSpPr>
-      <p:grpSpPr>
-        <a:xfrm>
-          <a:off x="0" y="0"/>
-          <a:ext cx="0" cy="0"/>
-          <a:chOff x="0" y="0"/>
-          <a:chExt cx="0" cy="0"/>
-        </a:xfrm>
-      </p:grpSpPr>
-      <p:sp>
-        <p:nvSpPr>
-          <p:cNvPr id="240" name="Shape 240"/>
-          <p:cNvSpPr>
-            <a:spLocks noGrp="1" noRot="1" noChangeAspect="1"/>
-          </p:cNvSpPr>
-          <p:nvPr>
-            <p:ph type="sldImg" idx="2"/>
-          </p:nvPr>
-        </p:nvSpPr>
-        <p:spPr>
-          <a:xfrm>
-            <a:off x="917575" y="746125"/>
-            <a:ext cx="4972050" cy="3729038"/>
-          </a:xfrm>
-          <a:custGeom>
-            <a:avLst/>
-            <a:gdLst/>
-            <a:ahLst/>
-            <a:cxnLst/>
-            <a:rect l="0" t="0" r="0" b="0"/>
-            <a:pathLst>
-              <a:path w="120000" h="120000" extrusionOk="0">
-                <a:moveTo>
-                  <a:pt x="0" y="0"/>
-                </a:moveTo>
-                <a:lnTo>
-                  <a:pt x="120000" y="0"/>
-                </a:lnTo>
-                <a:lnTo>
-                  <a:pt x="120000" y="120000"/>
-                </a:lnTo>
-                <a:lnTo>
-                  <a:pt x="0" y="120000"/>
-                </a:lnTo>
-                <a:close/>
-              </a:path>
-            </a:pathLst>
-          </a:custGeom>
-          <a:noFill/>
-          <a:ln w="12700" cap="flat" cmpd="sng">
-            <a:solidFill>
-              <a:srgbClr val="000000"/>
-            </a:solidFill>
-            <a:prstDash val="solid"/>
-            <a:round/>
-            <a:headEnd type="none" w="med" len="med"/>
-            <a:tailEnd type="none" w="med" len="med"/>
-          </a:ln>
-        </p:spPr>
-      </p:sp>
-      <p:sp>
-        <p:nvSpPr>
-          <p:cNvPr id="241" name="Shape 241"/>
-          <p:cNvSpPr txBox="1">
-            <a:spLocks noGrp="1"/>
-          </p:cNvSpPr>
-          <p:nvPr>
-            <p:ph type="body" idx="1"/>
-          </p:nvPr>
-        </p:nvSpPr>
-        <p:spPr>
-          <a:xfrm>
-            <a:off x="680562" y="4723448"/>
-            <a:ext cx="5444489" cy="4474845"/>
-          </a:xfrm>
-          <a:prstGeom prst="rect">
-            <a:avLst/>
-          </a:prstGeom>
-          <a:noFill/>
-          <a:ln>
-            <a:noFill/>
-          </a:ln>
-        </p:spPr>
-        <p:txBody>
-          <a:bodyPr lIns="91425" tIns="45700" rIns="91425" bIns="45700" anchor="t" anchorCtr="0">
-            <a:noAutofit/>
-          </a:bodyPr>
-          <a:lstStyle/>
-          <a:p>
-            <a:pPr marL="0" marR="0" lvl="0" indent="0" algn="l" rtl="0">
-              <a:spcBef>
-                <a:spcPts val="0"/>
-              </a:spcBef>
-              <a:buSzPct val="25000"/>
-              <a:buNone/>
-            </a:pPr>
-            <a:endParaRPr sz="1200" b="0" i="0" u="none" strike="noStrike" cap="none">
-              <a:solidFill>
-                <a:schemeClr val="dk1"/>
-              </a:solidFill>
-              <a:latin typeface="Calibri"/>
-              <a:ea typeface="Calibri"/>
-              <a:cs typeface="Calibri"/>
-              <a:sym typeface="Calibri"/>
-            </a:endParaRPr>
-          </a:p>
-        </p:txBody>
-      </p:sp>
-      <p:sp>
-        <p:nvSpPr>
-          <p:cNvPr id="242" name="Shape 242"/>
-          <p:cNvSpPr txBox="1">
-            <a:spLocks noGrp="1"/>
-          </p:cNvSpPr>
-          <p:nvPr>
-            <p:ph type="sldNum" idx="12"/>
-          </p:nvPr>
-        </p:nvSpPr>
-        <p:spPr>
-          <a:xfrm>
-            <a:off x="3854939" y="9445168"/>
-            <a:ext cx="2949099" cy="497205"/>
-          </a:xfrm>
-          <a:prstGeom prst="rect">
-            <a:avLst/>
-          </a:prstGeom>
-          <a:noFill/>
-          <a:ln>
-            <a:noFill/>
-          </a:ln>
-        </p:spPr>
-        <p:txBody>
-          <a:bodyPr lIns="91425" tIns="45700" rIns="91425" bIns="45700" anchor="b" anchorCtr="0">
-            <a:noAutofit/>
-          </a:bodyPr>
-          <a:lstStyle/>
-          <a:p>
-            <a:pPr marL="0" marR="0" lvl="0" indent="0" algn="r" rtl="0">
-              <a:spcBef>
-                <a:spcPts val="0"/>
-              </a:spcBef>
-              <a:buSzPct val="25000"/>
-              <a:buNone/>
-            </a:pPr>
-            <a:fld id="{00000000-1234-1234-1234-123412341234}" type="slidenum">
-              <a:rPr lang="en-US" sz="1200" b="0" i="0" u="none" strike="noStrike" cap="none">
-                <a:solidFill>
-                  <a:srgbClr val="000000"/>
-                </a:solidFill>
-                <a:latin typeface="Calibri"/>
-                <a:ea typeface="Calibri"/>
-                <a:cs typeface="Calibri"/>
-                <a:sym typeface="Calibri"/>
-              </a:rPr>
-              <a:t>1</a:t>
-            </a:fld>
-            <a:endParaRPr lang="en-US" sz="1200" b="0" i="0" u="none" strike="noStrike" cap="none">
-              <a:solidFill>
-                <a:srgbClr val="000000"/>
-              </a:solidFill>
-              <a:latin typeface="Calibri"/>
-              <a:ea typeface="Calibri"/>
-              <a:cs typeface="Calibri"/>
-              <a:sym typeface="Calibri"/>
-            </a:endParaRPr>
-          </a:p>
-        </p:txBody>
-      </p:sp>
-    </p:spTree>
-  </p:cSld>
-  <p:clrMapOvr>
-    <a:masterClrMapping/>
-  </p:clrMapOvr>
-</p:notes>
-</file>
-
 <file path=ppt/slideLayouts/slideLayout1.xml><?xml version="1.0" encoding="utf-8"?>
-<p:sldLayout xmlns:a="http://schemas.openxmlformats.org/drawingml/2006/main" xmlns:r="http://schemas.openxmlformats.org/officeDocument/2006/relationships" xmlns:p="http://schemas.openxmlformats.org/presentationml/2006/main">
-  <p:cSld name="Custom Layout">
-    <p:spTree>
-      <p:nvGrpSpPr>
-        <p:cNvPr id="1" name="Shape 188"/>
-        <p:cNvGrpSpPr/>
-        <p:nvPr/>
-      </p:nvGrpSpPr>
-      <p:grpSpPr>
-        <a:xfrm>
-          <a:off x="0" y="0"/>
-          <a:ext cx="0" cy="0"/>
-          <a:chOff x="0" y="0"/>
-          <a:chExt cx="0" cy="0"/>
-        </a:xfrm>
-      </p:grpSpPr>
-      <p:pic>
-        <p:nvPicPr>
-          <p:cNvPr id="189" name="Shape 189" descr="\\Server\D\jyoti\FI023_BITS_v1\styleguide img\IMG_5627_b.jpg"/>
-          <p:cNvPicPr preferRelativeResize="0"/>
-          <p:nvPr/>
-        </p:nvPicPr>
-        <p:blipFill rotWithShape="1">
-          <a:blip r:embed="rId2">
-            <a:alphaModFix/>
-          </a:blip>
-          <a:srcRect/>
-          <a:stretch/>
-        </p:blipFill>
-        <p:spPr>
-          <a:xfrm>
-            <a:off x="15" y="17"/>
-            <a:ext cx="9142380" cy="6882117"/>
-          </a:xfrm>
-          <a:prstGeom prst="rect">
-            <a:avLst/>
-          </a:prstGeom>
-          <a:noFill/>
-          <a:ln>
-            <a:noFill/>
-          </a:ln>
-        </p:spPr>
-      </p:pic>
-      <p:sp>
-        <p:nvSpPr>
-          <p:cNvPr id="190" name="Shape 190"/>
-          <p:cNvSpPr/>
-          <p:nvPr/>
-        </p:nvSpPr>
-        <p:spPr>
-          <a:xfrm>
-            <a:off x="0" y="4253985"/>
-            <a:ext cx="9144000" cy="2628136"/>
-          </a:xfrm>
-          <a:prstGeom prst="rect">
-            <a:avLst/>
-          </a:prstGeom>
-          <a:solidFill>
-            <a:schemeClr val="lt1"/>
-          </a:solidFill>
-          <a:ln>
-            <a:noFill/>
-          </a:ln>
-        </p:spPr>
-        <p:txBody>
-          <a:bodyPr lIns="93125" tIns="46550" rIns="93125" bIns="46550" anchor="ctr" anchorCtr="0">
-            <a:noAutofit/>
-          </a:bodyPr>
-          <a:lstStyle/>
-          <a:p>
-            <a:pPr marL="0" marR="0" lvl="0" indent="0" algn="ctr" rtl="0">
-              <a:spcBef>
-                <a:spcPts val="0"/>
-              </a:spcBef>
-              <a:spcAft>
-                <a:spcPts val="0"/>
-              </a:spcAft>
-              <a:buNone/>
-            </a:pPr>
-            <a:endParaRPr sz="1600" b="0" i="0" u="none" strike="noStrike" cap="none">
-              <a:solidFill>
-                <a:srgbClr val="FFFFFF"/>
-              </a:solidFill>
-              <a:latin typeface="Arial"/>
-              <a:ea typeface="Arial"/>
-              <a:cs typeface="Arial"/>
-              <a:sym typeface="Arial"/>
-            </a:endParaRPr>
-          </a:p>
-        </p:txBody>
-      </p:sp>
-      <p:pic>
-        <p:nvPicPr>
-          <p:cNvPr id="191" name="Shape 191" descr="Picture 7.png"/>
-          <p:cNvPicPr preferRelativeResize="0"/>
-          <p:nvPr/>
-        </p:nvPicPr>
-        <p:blipFill rotWithShape="1">
-          <a:blip r:embed="rId3">
-            <a:alphaModFix/>
-          </a:blip>
-          <a:srcRect l="1923" b="5335"/>
-          <a:stretch/>
-        </p:blipFill>
-        <p:spPr>
-          <a:xfrm>
-            <a:off x="6764470" y="15"/>
-            <a:ext cx="2237873" cy="706766"/>
-          </a:xfrm>
-          <a:prstGeom prst="rect">
-            <a:avLst/>
-          </a:prstGeom>
-          <a:noFill/>
-          <a:ln>
-            <a:noFill/>
-          </a:ln>
-        </p:spPr>
-      </p:pic>
-      <p:grpSp>
-        <p:nvGrpSpPr>
-          <p:cNvPr id="195" name="Shape 195"/>
-          <p:cNvGrpSpPr/>
-          <p:nvPr/>
-        </p:nvGrpSpPr>
-        <p:grpSpPr>
-          <a:xfrm>
-            <a:off x="6778635" y="691752"/>
-            <a:ext cx="2254818" cy="699729"/>
-            <a:chOff x="76200" y="2209800"/>
-            <a:chExt cx="2209799" cy="685799"/>
-          </a:xfrm>
-        </p:grpSpPr>
-        <p:sp>
-          <p:nvSpPr>
-            <p:cNvPr id="196" name="Shape 196"/>
-            <p:cNvSpPr txBox="1"/>
-            <p:nvPr/>
-          </p:nvSpPr>
-          <p:spPr>
-            <a:xfrm>
-              <a:off x="76200" y="2209800"/>
-              <a:ext cx="2209799" cy="553997"/>
-            </a:xfrm>
-            <a:prstGeom prst="rect">
-              <a:avLst/>
-            </a:prstGeom>
-            <a:noFill/>
-            <a:ln>
-              <a:noFill/>
-            </a:ln>
-          </p:spPr>
-          <p:txBody>
-            <a:bodyPr lIns="91425" tIns="45700" rIns="91425" bIns="45700" anchor="t" anchorCtr="0">
-              <a:noAutofit/>
-            </a:bodyPr>
-            <a:lstStyle/>
-            <a:p>
-              <a:pPr marL="0" marR="0" lvl="0" indent="0" algn="ctr" rtl="0">
-                <a:spcBef>
-                  <a:spcPts val="0"/>
-                </a:spcBef>
-                <a:spcAft>
-                  <a:spcPts val="0"/>
-                </a:spcAft>
-                <a:buSzPct val="25000"/>
-                <a:buNone/>
-              </a:pPr>
-              <a:r>
-                <a:rPr lang="en-US" sz="3000" b="1" i="0" u="none" strike="noStrike" cap="none" dirty="0">
-                  <a:solidFill>
-                    <a:srgbClr val="FFFFFF"/>
-                  </a:solidFill>
-                  <a:latin typeface="Arial"/>
-                  <a:ea typeface="Arial"/>
-                  <a:cs typeface="Arial"/>
-                  <a:sym typeface="Arial"/>
-                </a:rPr>
-                <a:t>BITS</a:t>
-              </a:r>
-              <a:r>
-                <a:rPr lang="en-US" sz="3000" b="0" i="0" u="none" strike="noStrike" cap="none" dirty="0">
-                  <a:solidFill>
-                    <a:srgbClr val="FFFFFF"/>
-                  </a:solidFill>
-                  <a:latin typeface="Arial"/>
-                  <a:ea typeface="Arial"/>
-                  <a:cs typeface="Arial"/>
-                  <a:sym typeface="Arial"/>
-                </a:rPr>
-                <a:t> Pilani</a:t>
-              </a:r>
-            </a:p>
-          </p:txBody>
-        </p:sp>
-        <p:sp>
-          <p:nvSpPr>
-            <p:cNvPr id="197" name="Shape 197"/>
-            <p:cNvSpPr txBox="1"/>
-            <p:nvPr/>
-          </p:nvSpPr>
-          <p:spPr>
-            <a:xfrm>
-              <a:off x="228600" y="2664767"/>
-              <a:ext cx="1904999" cy="230832"/>
-            </a:xfrm>
-            <a:prstGeom prst="rect">
-              <a:avLst/>
-            </a:prstGeom>
-            <a:noFill/>
-            <a:ln>
-              <a:noFill/>
-            </a:ln>
-          </p:spPr>
-          <p:txBody>
-            <a:bodyPr lIns="91425" tIns="45700" rIns="91425" bIns="45700" anchor="t" anchorCtr="0">
-              <a:noAutofit/>
-            </a:bodyPr>
-            <a:lstStyle/>
-            <a:p>
-              <a:pPr marL="0" marR="0" lvl="0" indent="0" algn="ctr" rtl="0">
-                <a:spcBef>
-                  <a:spcPts val="0"/>
-                </a:spcBef>
-                <a:spcAft>
-                  <a:spcPts val="0"/>
-                </a:spcAft>
-                <a:buSzPct val="25000"/>
-                <a:buNone/>
-              </a:pPr>
-              <a:r>
-                <a:rPr lang="en-US" sz="900" b="0" i="0" u="none" strike="noStrike" cap="none">
-                  <a:solidFill>
-                    <a:srgbClr val="FFFFFF"/>
-                  </a:solidFill>
-                  <a:latin typeface="Arial"/>
-                  <a:ea typeface="Arial"/>
-                  <a:cs typeface="Arial"/>
-                  <a:sym typeface="Arial"/>
-                </a:rPr>
-                <a:t>Pilani | Dubai | Goa | Hyderabad</a:t>
-              </a:r>
-            </a:p>
-          </p:txBody>
-        </p:sp>
-      </p:grpSp>
-      <p:sp>
-        <p:nvSpPr>
-          <p:cNvPr id="198" name="Shape 198"/>
-          <p:cNvSpPr txBox="1">
-            <a:spLocks noGrp="1"/>
-          </p:cNvSpPr>
-          <p:nvPr>
-            <p:ph type="ctrTitle"/>
-          </p:nvPr>
-        </p:nvSpPr>
-        <p:spPr>
-          <a:xfrm>
-            <a:off x="320728" y="5237530"/>
-            <a:ext cx="6199129" cy="1051102"/>
-          </a:xfrm>
-          <a:prstGeom prst="rect">
-            <a:avLst/>
-          </a:prstGeom>
-          <a:noFill/>
-          <a:ln>
-            <a:noFill/>
-          </a:ln>
-        </p:spPr>
-        <p:txBody>
-          <a:bodyPr lIns="91425" tIns="91425" rIns="91425" bIns="91425" anchor="b" anchorCtr="0"/>
-          <a:lstStyle>
-            <a:lvl1pPr marL="0" marR="0" lvl="0" indent="0" algn="l" rtl="0">
-              <a:spcBef>
-                <a:spcPts val="0"/>
-              </a:spcBef>
-              <a:spcAft>
-                <a:spcPts val="0"/>
-              </a:spcAft>
-              <a:defRPr/>
-            </a:lvl1pPr>
-            <a:lvl2pPr marL="0" marR="0" lvl="1" indent="0" algn="l" rtl="0">
-              <a:spcBef>
-                <a:spcPts val="0"/>
-              </a:spcBef>
-              <a:spcAft>
-                <a:spcPts val="0"/>
-              </a:spcAft>
-              <a:defRPr/>
-            </a:lvl2pPr>
-            <a:lvl3pPr marL="0" marR="0" lvl="2" indent="0" algn="l" rtl="0">
-              <a:spcBef>
-                <a:spcPts val="0"/>
-              </a:spcBef>
-              <a:spcAft>
-                <a:spcPts val="0"/>
-              </a:spcAft>
-              <a:defRPr/>
-            </a:lvl3pPr>
-            <a:lvl4pPr marL="0" marR="0" lvl="3" indent="0" algn="l" rtl="0">
-              <a:spcBef>
-                <a:spcPts val="0"/>
-              </a:spcBef>
-              <a:spcAft>
-                <a:spcPts val="0"/>
-              </a:spcAft>
-              <a:defRPr/>
-            </a:lvl4pPr>
-            <a:lvl5pPr marL="0" marR="0" lvl="4" indent="0" algn="l" rtl="0">
-              <a:spcBef>
-                <a:spcPts val="0"/>
-              </a:spcBef>
-              <a:spcAft>
-                <a:spcPts val="0"/>
-              </a:spcAft>
-              <a:defRPr/>
-            </a:lvl5pPr>
-            <a:lvl6pPr marL="465681" marR="0" lvl="5" indent="-8481" algn="l" rtl="0">
-              <a:spcBef>
-                <a:spcPts val="0"/>
-              </a:spcBef>
-              <a:spcAft>
-                <a:spcPts val="0"/>
-              </a:spcAft>
-              <a:defRPr/>
-            </a:lvl6pPr>
-            <a:lvl7pPr marL="931383" marR="0" lvl="6" indent="-4282" algn="l" rtl="0">
-              <a:spcBef>
-                <a:spcPts val="0"/>
-              </a:spcBef>
-              <a:spcAft>
-                <a:spcPts val="0"/>
-              </a:spcAft>
-              <a:defRPr/>
-            </a:lvl7pPr>
-            <a:lvl8pPr marL="1397075" marR="0" lvl="7" indent="-74" algn="l" rtl="0">
-              <a:spcBef>
-                <a:spcPts val="0"/>
-              </a:spcBef>
-              <a:spcAft>
-                <a:spcPts val="0"/>
-              </a:spcAft>
-              <a:defRPr/>
-            </a:lvl8pPr>
-            <a:lvl9pPr marL="1862760" marR="0" lvl="8" indent="-8560" algn="l" rtl="0">
-              <a:spcBef>
-                <a:spcPts val="0"/>
-              </a:spcBef>
-              <a:spcAft>
-                <a:spcPts val="0"/>
-              </a:spcAft>
-              <a:defRPr/>
-            </a:lvl9pPr>
-          </a:lstStyle>
-          <a:p>
-            <a:endParaRPr dirty="0"/>
-          </a:p>
-        </p:txBody>
-      </p:sp>
-      <p:grpSp>
-        <p:nvGrpSpPr>
-          <p:cNvPr id="13" name="Group 12"/>
-          <p:cNvGrpSpPr/>
-          <p:nvPr userDrawn="1"/>
-        </p:nvGrpSpPr>
-        <p:grpSpPr>
-          <a:xfrm>
-            <a:off x="1" y="6814184"/>
-            <a:ext cx="9144000" cy="72389"/>
-            <a:chOff x="1998227" y="6500996"/>
-            <a:chExt cx="7153215" cy="46648"/>
-          </a:xfrm>
-        </p:grpSpPr>
-        <p:sp>
-          <p:nvSpPr>
-            <p:cNvPr id="14" name="Shape 170"/>
-            <p:cNvSpPr/>
-            <p:nvPr/>
-          </p:nvSpPr>
-          <p:spPr>
-            <a:xfrm>
-              <a:off x="4408551" y="6500996"/>
-              <a:ext cx="2376028" cy="46648"/>
-            </a:xfrm>
-            <a:prstGeom prst="rect">
-              <a:avLst/>
-            </a:prstGeom>
-            <a:solidFill>
-              <a:srgbClr val="76C2E5"/>
-            </a:solidFill>
-            <a:ln>
-              <a:noFill/>
-            </a:ln>
-          </p:spPr>
-          <p:txBody>
-            <a:bodyPr lIns="93125" tIns="46550" rIns="93125" bIns="46550" anchor="ctr" anchorCtr="0">
-              <a:noAutofit/>
-            </a:bodyPr>
-            <a:lstStyle/>
-            <a:p>
-              <a:pPr marL="0" marR="0" lvl="0" indent="0" algn="ctr" rtl="0">
-                <a:spcBef>
-                  <a:spcPts val="0"/>
-                </a:spcBef>
-                <a:spcAft>
-                  <a:spcPts val="0"/>
-                </a:spcAft>
-                <a:buNone/>
-              </a:pPr>
-              <a:endParaRPr sz="1600" b="0" i="0" u="none" strike="noStrike" cap="none">
-                <a:solidFill>
-                  <a:srgbClr val="FFFFFF"/>
-                </a:solidFill>
-                <a:latin typeface="Arial"/>
-                <a:ea typeface="Arial"/>
-                <a:cs typeface="Arial"/>
-                <a:sym typeface="Arial"/>
-              </a:endParaRPr>
-            </a:p>
-          </p:txBody>
-        </p:sp>
-        <p:sp>
-          <p:nvSpPr>
-            <p:cNvPr id="15" name="Shape 171"/>
-            <p:cNvSpPr/>
-            <p:nvPr/>
-          </p:nvSpPr>
-          <p:spPr>
-            <a:xfrm>
-              <a:off x="1998227" y="6500996"/>
-              <a:ext cx="2410322" cy="46648"/>
-            </a:xfrm>
-            <a:prstGeom prst="rect">
-              <a:avLst/>
-            </a:prstGeom>
-            <a:solidFill>
-              <a:srgbClr val="FCB017"/>
-            </a:solidFill>
-            <a:ln>
-              <a:noFill/>
-            </a:ln>
-          </p:spPr>
-          <p:txBody>
-            <a:bodyPr lIns="93125" tIns="46550" rIns="93125" bIns="46550" anchor="ctr" anchorCtr="0">
-              <a:noAutofit/>
-            </a:bodyPr>
-            <a:lstStyle/>
-            <a:p>
-              <a:pPr marL="0" marR="0" lvl="0" indent="0" algn="ctr" rtl="0">
-                <a:spcBef>
-                  <a:spcPts val="0"/>
-                </a:spcBef>
-                <a:spcAft>
-                  <a:spcPts val="0"/>
-                </a:spcAft>
-                <a:buNone/>
-              </a:pPr>
-              <a:endParaRPr sz="1600" b="0" i="0" u="none" strike="noStrike" cap="none">
-                <a:solidFill>
-                  <a:srgbClr val="FFFFFF"/>
-                </a:solidFill>
-                <a:latin typeface="Arial"/>
-                <a:ea typeface="Arial"/>
-                <a:cs typeface="Arial"/>
-                <a:sym typeface="Arial"/>
-              </a:endParaRPr>
-            </a:p>
-          </p:txBody>
-        </p:sp>
-        <p:sp>
-          <p:nvSpPr>
-            <p:cNvPr id="16" name="Shape 172"/>
-            <p:cNvSpPr/>
-            <p:nvPr/>
-          </p:nvSpPr>
-          <p:spPr>
-            <a:xfrm>
-              <a:off x="6775414" y="6500996"/>
-              <a:ext cx="2376028" cy="46648"/>
-            </a:xfrm>
-            <a:prstGeom prst="rect">
-              <a:avLst/>
-            </a:prstGeom>
-            <a:solidFill>
-              <a:srgbClr val="FF0000"/>
-            </a:solidFill>
-            <a:ln>
-              <a:noFill/>
-            </a:ln>
-          </p:spPr>
-          <p:txBody>
-            <a:bodyPr lIns="93125" tIns="46550" rIns="93125" bIns="46550" anchor="ctr" anchorCtr="0">
-              <a:noAutofit/>
-            </a:bodyPr>
-            <a:lstStyle/>
-            <a:p>
-              <a:pPr marL="0" marR="0" lvl="0" indent="0" algn="ctr" rtl="0">
-                <a:spcBef>
-                  <a:spcPts val="0"/>
-                </a:spcBef>
-                <a:spcAft>
-                  <a:spcPts val="0"/>
-                </a:spcAft>
-                <a:buNone/>
-              </a:pPr>
-              <a:endParaRPr sz="1600" b="0" i="0" u="none" strike="noStrike" cap="none">
-                <a:solidFill>
-                  <a:srgbClr val="FFFFFF"/>
-                </a:solidFill>
-                <a:latin typeface="Arial"/>
-                <a:ea typeface="Arial"/>
-                <a:cs typeface="Arial"/>
-                <a:sym typeface="Arial"/>
-              </a:endParaRPr>
-            </a:p>
-          </p:txBody>
-        </p:sp>
-      </p:grpSp>
-      <p:sp>
-        <p:nvSpPr>
-          <p:cNvPr id="17" name="Shape 198"/>
-          <p:cNvSpPr txBox="1">
-            <a:spLocks/>
-          </p:cNvSpPr>
-          <p:nvPr userDrawn="1"/>
-        </p:nvSpPr>
-        <p:spPr>
-          <a:xfrm>
-            <a:off x="320728" y="4374693"/>
-            <a:ext cx="6199129" cy="858385"/>
-          </a:xfrm>
-          <a:prstGeom prst="rect">
-            <a:avLst/>
-          </a:prstGeom>
-          <a:noFill/>
-          <a:ln>
-            <a:noFill/>
-          </a:ln>
-        </p:spPr>
-        <p:txBody>
-          <a:bodyPr lIns="91425" tIns="91425" rIns="91425" bIns="91425" anchor="b" anchorCtr="0"/>
-          <a:lstStyle>
-            <a:defPPr marR="0" lvl="0" algn="l" rtl="0">
-              <a:lnSpc>
-                <a:spcPct val="100000"/>
-              </a:lnSpc>
-              <a:spcBef>
-                <a:spcPts val="0"/>
-              </a:spcBef>
-              <a:spcAft>
-                <a:spcPts val="0"/>
-              </a:spcAft>
-            </a:defPPr>
-            <a:lvl1pPr marL="0" marR="0" lvl="0" indent="0" algn="l" rtl="0">
-              <a:lnSpc>
-                <a:spcPct val="100000"/>
-              </a:lnSpc>
-              <a:spcBef>
-                <a:spcPts val="0"/>
-              </a:spcBef>
-              <a:spcAft>
-                <a:spcPts val="0"/>
-              </a:spcAft>
-              <a:buNone/>
-              <a:defRPr sz="1400" b="0" i="0" u="none" strike="noStrike" cap="none">
-                <a:solidFill>
-                  <a:srgbClr val="000000"/>
-                </a:solidFill>
-                <a:latin typeface="Arial"/>
-                <a:ea typeface="Arial"/>
-                <a:cs typeface="Arial"/>
-                <a:sym typeface="Arial"/>
-              </a:defRPr>
-            </a:lvl1pPr>
-            <a:lvl2pPr marL="0" marR="0" lvl="1" indent="0" algn="l" rtl="0">
-              <a:spcBef>
-                <a:spcPts val="0"/>
-              </a:spcBef>
-              <a:spcAft>
-                <a:spcPts val="0"/>
-              </a:spcAft>
-              <a:defRPr/>
-            </a:lvl2pPr>
-            <a:lvl3pPr marL="0" marR="0" lvl="2" indent="0" algn="l" rtl="0">
-              <a:spcBef>
-                <a:spcPts val="0"/>
-              </a:spcBef>
-              <a:spcAft>
-                <a:spcPts val="0"/>
-              </a:spcAft>
-              <a:defRPr/>
-            </a:lvl3pPr>
-            <a:lvl4pPr marL="0" marR="0" lvl="3" indent="0" algn="l" rtl="0">
-              <a:spcBef>
-                <a:spcPts val="0"/>
-              </a:spcBef>
-              <a:spcAft>
-                <a:spcPts val="0"/>
-              </a:spcAft>
-              <a:defRPr/>
-            </a:lvl4pPr>
-            <a:lvl5pPr marL="0" marR="0" lvl="4" indent="0" algn="l" rtl="0">
-              <a:spcBef>
-                <a:spcPts val="0"/>
-              </a:spcBef>
-              <a:spcAft>
-                <a:spcPts val="0"/>
-              </a:spcAft>
-              <a:defRPr/>
-            </a:lvl5pPr>
-            <a:lvl6pPr marL="465681" marR="0" lvl="5" indent="-8481" algn="l" rtl="0">
-              <a:spcBef>
-                <a:spcPts val="0"/>
-              </a:spcBef>
-              <a:spcAft>
-                <a:spcPts val="0"/>
-              </a:spcAft>
-              <a:defRPr/>
-            </a:lvl6pPr>
-            <a:lvl7pPr marL="931383" marR="0" lvl="6" indent="-4282" algn="l" rtl="0">
-              <a:spcBef>
-                <a:spcPts val="0"/>
-              </a:spcBef>
-              <a:spcAft>
-                <a:spcPts val="0"/>
-              </a:spcAft>
-              <a:defRPr/>
-            </a:lvl7pPr>
-            <a:lvl8pPr marL="1397075" marR="0" lvl="7" indent="-74" algn="l" rtl="0">
-              <a:spcBef>
-                <a:spcPts val="0"/>
-              </a:spcBef>
-              <a:spcAft>
-                <a:spcPts val="0"/>
-              </a:spcAft>
-              <a:defRPr/>
-            </a:lvl8pPr>
-            <a:lvl9pPr marL="1862760" marR="0" lvl="8" indent="-8560" algn="l" rtl="0">
-              <a:spcBef>
-                <a:spcPts val="0"/>
-              </a:spcBef>
-              <a:spcAft>
-                <a:spcPts val="0"/>
-              </a:spcAft>
-              <a:defRPr/>
-            </a:lvl9pPr>
-          </a:lstStyle>
-          <a:p>
-            <a:endParaRPr lang="en-IN" dirty="0"/>
-          </a:p>
-        </p:txBody>
-      </p:sp>
-    </p:spTree>
-  </p:cSld>
-  <p:clrMapOvr>
-    <a:masterClrMapping/>
-  </p:clrMapOvr>
-</p:sldLayout>
-</file>
-
-<file path=ppt/slideLayouts/slideLayout2.xml><?xml version="1.0" encoding="utf-8"?>
 <p:sldLayout xmlns:a="http://schemas.openxmlformats.org/drawingml/2006/main" xmlns:r="http://schemas.openxmlformats.org/officeDocument/2006/relationships" xmlns:p="http://schemas.openxmlformats.org/presentationml/2006/main" type="titleOnly">
   <p:cSld name="Title Only">
     <p:spTree>
@@ -1965,7 +1116,7 @@
 </p:sldLayout>
 </file>
 
-<file path=ppt/slideLayouts/slideLayout3.xml><?xml version="1.0" encoding="utf-8"?>
+<file path=ppt/slideLayouts/slideLayout2.xml><?xml version="1.0" encoding="utf-8"?>
 <p:sldLayout xmlns:a="http://schemas.openxmlformats.org/drawingml/2006/main" xmlns:r="http://schemas.openxmlformats.org/officeDocument/2006/relationships" xmlns:p="http://schemas.openxmlformats.org/presentationml/2006/main">
   <p:cSld name="Title Slide">
     <p:bg>
@@ -2600,7 +1751,7 @@
           <p:nvPr userDrawn="1"/>
         </p:nvPicPr>
         <p:blipFill rotWithShape="1">
-          <a:blip r:embed="rId5">
+          <a:blip r:embed="rId4">
             <a:alphaModFix/>
           </a:blip>
           <a:srcRect t="2" b="28592"/>
@@ -2686,9 +1837,8 @@
   </p:cSld>
   <p:clrMap bg1="lt1" tx1="dk1" bg2="dk2" tx2="lt2" accent1="accent1" accent2="accent2" accent3="accent3" accent4="accent4" accent5="accent5" accent6="accent6" hlink="hlink" folHlink="folHlink"/>
   <p:sldLayoutIdLst>
-    <p:sldLayoutId id="2147483663" r:id="rId1"/>
-    <p:sldLayoutId id="2147483661" r:id="rId2"/>
-    <p:sldLayoutId id="2147483669" r:id="rId3"/>
+    <p:sldLayoutId id="2147483661" r:id="rId1"/>
+    <p:sldLayoutId id="2147483669" r:id="rId2"/>
   </p:sldLayoutIdLst>
   <p:hf sldNum="0" hdr="0" ftr="0" dt="0"/>
   <p:txStyles>
@@ -3139,88 +2289,6 @@
   <p:cSld>
     <p:spTree>
       <p:nvGrpSpPr>
-        <p:cNvPr id="1" name="Shape 243"/>
-        <p:cNvGrpSpPr/>
-        <p:nvPr/>
-      </p:nvGrpSpPr>
-      <p:grpSpPr>
-        <a:xfrm>
-          <a:off x="0" y="0"/>
-          <a:ext cx="0" cy="0"/>
-          <a:chOff x="0" y="0"/>
-          <a:chExt cx="0" cy="0"/>
-        </a:xfrm>
-      </p:grpSpPr>
-      <p:sp>
-        <p:nvSpPr>
-          <p:cNvPr id="244" name="Shape 244"/>
-          <p:cNvSpPr txBox="1">
-            <a:spLocks noGrp="1"/>
-          </p:cNvSpPr>
-          <p:nvPr>
-            <p:ph type="ctrTitle"/>
-          </p:nvPr>
-        </p:nvSpPr>
-        <p:spPr>
-          <a:xfrm>
-            <a:off x="273103" y="4570780"/>
-            <a:ext cx="7305708" cy="1434604"/>
-          </a:xfrm>
-          <a:prstGeom prst="rect">
-            <a:avLst/>
-          </a:prstGeom>
-          <a:noFill/>
-          <a:ln>
-            <a:noFill/>
-          </a:ln>
-        </p:spPr>
-        <p:txBody>
-          <a:bodyPr lIns="91400" tIns="45700" rIns="91400" bIns="45700" anchor="ctr" anchorCtr="0">
-            <a:noAutofit/>
-          </a:bodyPr>
-          <a:lstStyle/>
-          <a:p>
-            <a:pPr marL="0" marR="0" lvl="0" indent="0" rtl="0">
-              <a:lnSpc>
-                <a:spcPct val="111111"/>
-              </a:lnSpc>
-              <a:spcBef>
-                <a:spcPts val="0"/>
-              </a:spcBef>
-              <a:buClr>
-                <a:schemeClr val="lt1"/>
-              </a:buClr>
-              <a:buSzPct val="25000"/>
-              <a:buFont typeface="Arial"/>
-              <a:buNone/>
-            </a:pPr>
-            <a:r>
-              <a:rPr lang="en-US" sz="4400" i="0" u="none" strike="noStrike" cap="none" dirty="0">
-                <a:solidFill>
-                  <a:schemeClr val="tx1"/>
-                </a:solidFill>
-                <a:latin typeface="Calibri" panose="020F0502020204030204" pitchFamily="34" charset="0"/>
-                <a:cs typeface="Calibri" panose="020F0502020204030204" pitchFamily="34" charset="0"/>
-                <a:sym typeface="Arial"/>
-              </a:rPr>
-              <a:t>Wireless Sensor Network – Time Sync Protocols </a:t>
-            </a:r>
-          </a:p>
-        </p:txBody>
-      </p:sp>
-    </p:spTree>
-  </p:cSld>
-  <p:clrMapOvr>
-    <a:masterClrMapping/>
-  </p:clrMapOvr>
-</p:sld>
-</file>
-
-<file path=ppt/slides/slide2.xml><?xml version="1.0" encoding="utf-8"?>
-<p:sld xmlns:a="http://schemas.openxmlformats.org/drawingml/2006/main" xmlns:r="http://schemas.openxmlformats.org/officeDocument/2006/relationships" xmlns:p="http://schemas.openxmlformats.org/presentationml/2006/main">
-  <p:cSld>
-    <p:spTree>
-      <p:nvGrpSpPr>
         <p:cNvPr id="1" name=""/>
         <p:cNvGrpSpPr/>
         <p:nvPr/>
@@ -3472,7 +2540,7 @@
 </p:sld>
 </file>
 
-<file path=ppt/slides/slide3.xml><?xml version="1.0" encoding="utf-8"?>
+<file path=ppt/slides/slide2.xml><?xml version="1.0" encoding="utf-8"?>
 <p:sld xmlns:a="http://schemas.openxmlformats.org/drawingml/2006/main" xmlns:r="http://schemas.openxmlformats.org/officeDocument/2006/relationships" xmlns:p="http://schemas.openxmlformats.org/presentationml/2006/main">
   <p:cSld>
     <p:spTree>
@@ -3897,7 +2965,7 @@
 </p:sld>
 </file>
 
-<file path=ppt/slides/slide4.xml><?xml version="1.0" encoding="utf-8"?>
+<file path=ppt/slides/slide3.xml><?xml version="1.0" encoding="utf-8"?>
 <p:sld xmlns:a="http://schemas.openxmlformats.org/drawingml/2006/main" xmlns:r="http://schemas.openxmlformats.org/officeDocument/2006/relationships" xmlns:p="http://schemas.openxmlformats.org/presentationml/2006/main">
   <p:cSld>
     <p:spTree>
@@ -6245,7 +5313,7 @@
 </p:sld>
 </file>
 
-<file path=ppt/slides/slide5.xml><?xml version="1.0" encoding="utf-8"?>
+<file path=ppt/slides/slide4.xml><?xml version="1.0" encoding="utf-8"?>
 <p:sld xmlns:a="http://schemas.openxmlformats.org/drawingml/2006/main" xmlns:r="http://schemas.openxmlformats.org/officeDocument/2006/relationships" xmlns:p="http://schemas.openxmlformats.org/presentationml/2006/main">
   <p:cSld>
     <p:spTree>
@@ -8834,7 +7902,7 @@
 </p:sld>
 </file>
 
-<file path=ppt/slides/slide6.xml><?xml version="1.0" encoding="utf-8"?>
+<file path=ppt/slides/slide5.xml><?xml version="1.0" encoding="utf-8"?>
 <p:sld xmlns:a="http://schemas.openxmlformats.org/drawingml/2006/main" xmlns:r="http://schemas.openxmlformats.org/officeDocument/2006/relationships" xmlns:p="http://schemas.openxmlformats.org/presentationml/2006/main">
   <p:cSld>
     <p:spTree>
@@ -9989,7 +9057,7 @@
 </p:sld>
 </file>
 
-<file path=ppt/slides/slide7.xml><?xml version="1.0" encoding="utf-8"?>
+<file path=ppt/slides/slide6.xml><?xml version="1.0" encoding="utf-8"?>
 <p:sld xmlns:a="http://schemas.openxmlformats.org/drawingml/2006/main" xmlns:r="http://schemas.openxmlformats.org/officeDocument/2006/relationships" xmlns:p="http://schemas.openxmlformats.org/presentationml/2006/main">
   <p:cSld>
     <p:spTree>
@@ -10373,7 +9441,7 @@
 </p:sld>
 </file>
 
-<file path=ppt/slides/slide8.xml><?xml version="1.0" encoding="utf-8"?>
+<file path=ppt/slides/slide7.xml><?xml version="1.0" encoding="utf-8"?>
 <p:sld xmlns:a="http://schemas.openxmlformats.org/drawingml/2006/main" xmlns:r="http://schemas.openxmlformats.org/officeDocument/2006/relationships" xmlns:p="http://schemas.openxmlformats.org/presentationml/2006/main">
   <p:cSld>
     <p:spTree>
@@ -13398,7 +12466,7 @@
 </p:sld>
 </file>
 
-<file path=ppt/slides/slide9.xml><?xml version="1.0" encoding="utf-8"?>
+<file path=ppt/slides/slide8.xml><?xml version="1.0" encoding="utf-8"?>
 <p:sld xmlns:a="http://schemas.openxmlformats.org/drawingml/2006/main" xmlns:r="http://schemas.openxmlformats.org/officeDocument/2006/relationships" xmlns:p="http://schemas.openxmlformats.org/presentationml/2006/main">
   <p:cSld>
     <p:spTree>

</xml_diff>